<commit_message>
Update the producer visit pack: phone Manejo sheet, instructivo, and 4 slides.
Co-authored-by: Cursor <cursoragent@cursor.com>
</commit_message>
<xml_diff>
--- a/Gemelo-Digital-Ganadero-productores.pptx
+++ b/Gemelo-Digital-Ganadero-productores.pptx
@@ -8,6 +8,7 @@
     <p:sldId id="256" r:id="rId7"/>
     <p:sldId id="257" r:id="rId8"/>
     <p:sldId id="258" r:id="rId9"/>
+    <p:sldId id="259" r:id="rId10"/>
   </p:sldIdLst>
   <p:sldSz cx="12191695" cy="6858000" type="screen4x3"/>
   <p:notesSz cx="6858000" cy="9144000"/>
@@ -3279,7 +3280,7 @@
                 </a:solidFill>
                 <a:latin typeface="Calibri"/>
               </a:rPr>
-              <a:t>▸  Demostrativo: 500 ha · La Calera (SW Belgrano).</a:t>
+              <a:t>▸  Se abre un campo de ejemplo en Belgrano. Después, el del productor.</a:t>
             </a:r>
           </a:p>
           <a:p>
@@ -3595,7 +3596,7 @@
                 </a:solidFill>
                 <a:latin typeface="Calibri"/>
               </a:rPr>
-              <a:t>INTA REGIÓN III  ·  ACTUAL  ·  MEJORADO 1  ·  ÓPTIMO</a:t>
+              <a:t>INTA REGIÓN III  ·  INICIAL  ·  MEJORANDO  ·  IDEAL  ·  AÑO COMPLETO</a:t>
             </a:r>
           </a:p>
         </p:txBody>
@@ -3663,7 +3664,7 @@
                 </a:solidFill>
                 <a:latin typeface="Calibri"/>
               </a:rPr>
-              <a:t>Toque cada recuadro (o clic en presentación). Números de zona INTA; en su campo se lee ese lote.</a:t>
+              <a:t>El invierno limita cuántos animales se mantienen. Números INTA de zona; en su campo se lee ese lote.</a:t>
             </a:r>
           </a:p>
         </p:txBody>
@@ -3719,7 +3720,7 @@
                 </a:solidFill>
                 <a:latin typeface="Calibri"/>
               </a:rPr>
-              <a:t>HOY</a:t>
+              <a:t>INICIAL</a:t>
             </a:r>
           </a:p>
           <a:p>
@@ -3753,7 +3754,7 @@
               </a:rPr>
               <a:t>Destete ~62 %
 ~5,9 kg carne/ha
-Carga alta, agua a veces lejos.</a:t>
+Cómo está hoy el lote.</a:t>
             </a:r>
           </a:p>
         </p:txBody>
@@ -3809,7 +3810,7 @@
                 </a:solidFill>
                 <a:latin typeface="Calibri"/>
               </a:rPr>
-              <a:t>MEJORADO 1</a:t>
+              <a:t>MEJORANDO</a:t>
             </a:r>
           </a:p>
           <a:p>
@@ -3843,8 +3844,8 @@
               </a:rPr>
               <a:t>Destete ~85 %
 ~12 kg/ha
-Rotar, descansar, bebida cerca.
-Sin desmonte.</a:t>
+Rotar, dividir, aguada cerca.
+Sembrar 1–2 ha. Sin desmonte.</a:t>
             </a:r>
           </a:p>
         </p:txBody>
@@ -3900,7 +3901,7 @@
                 </a:solidFill>
                 <a:latin typeface="Calibri"/>
               </a:rPr>
-              <a:t>ÓPTIMO</a:t>
+              <a:t>IDEAL</a:t>
             </a:r>
           </a:p>
           <a:p>
@@ -3916,7 +3917,7 @@
                 </a:solidFill>
                 <a:latin typeface="Georgia"/>
               </a:rPr>
-              <a:t>Agua + manejo</a:t>
+              <a:t>Techo INTA</a:t>
             </a:r>
           </a:p>
           <a:p>
@@ -3932,10 +3933,9 @@
                 </a:solidFill>
                 <a:latin typeface="Calibri"/>
               </a:rPr>
-              <a:t>Destete ~90 %
-Hasta 22–25 kg/ha
-Inversión de agua. Buffel
-solo si OTBN lo permite.</a:t>
+              <a:t>Destete ~90 % en bajo
+En loma no pasa de Mejorando.
+Buffel solo si OTBN lo permite.</a:t>
             </a:r>
           </a:p>
         </p:txBody>
@@ -4358,7 +4358,7 @@
                 </a:solidFill>
                 <a:latin typeface="Calibri"/>
               </a:rPr>
-              <a:t>CÓMO SE USA  ·  UNA VISITA AL PRODUCTOR</a:t>
+              <a:t>DIAGNÓSTICO  ·  OFERTA Y CARGA MES A MES</a:t>
             </a:r>
           </a:p>
         </p:txBody>
@@ -4392,21 +4392,55 @@
                 </a:solidFill>
                 <a:latin typeface="Georgia"/>
               </a:rPr>
-              <a:t>Tres pasos.</a:t>
-            </a:r>
-          </a:p>
-        </p:txBody>
-      </p:sp>
-      <p:sp>
-        <p:nvSpPr>
-          <p:cNvPr id="5" name="Rounded Rectangle 4"/>
+              <a:t>Cuándo actuar.</a:t>
+            </a:r>
+          </a:p>
+        </p:txBody>
+      </p:sp>
+      <p:sp>
+        <p:nvSpPr>
+          <p:cNvPr id="5" name="TextBox 4"/>
+          <p:cNvSpPr txBox="1"/>
+          <p:nvPr/>
+        </p:nvSpPr>
+        <p:spPr>
+          <a:xfrm>
+            <a:off x="457200" y="1417320"/>
+            <a:ext cx="11155680" cy="365760"/>
+          </a:xfrm>
+          <a:prstGeom prst="rect">
+            <a:avLst/>
+          </a:prstGeom>
+          <a:noFill/>
+        </p:spPr>
+        <p:txBody>
+          <a:bodyPr wrap="none">
+            <a:spAutoFit/>
+          </a:bodyPr>
+          <a:lstStyle/>
+          <a:p>
+            <a:r>
+              <a:rPr sz="1600">
+                <a:solidFill>
+                  <a:srgbClr val="F7F1E4"/>
+                </a:solidFill>
+                <a:latin typeface="Calibri"/>
+              </a:rPr>
+              <a:t>Verde = pasto del mes.  Oro = lo que comen.  Rojo = ese mes hay que intervenir.</a:t>
+            </a:r>
+          </a:p>
+        </p:txBody>
+      </p:sp>
+      <p:sp>
+        <p:nvSpPr>
+          <p:cNvPr id="6" name="Rounded Rectangle 5"/>
           <p:cNvSpPr/>
           <p:nvPr/>
         </p:nvSpPr>
         <p:spPr>
           <a:xfrm>
-            <a:off x="457200" y="1691640"/>
-            <a:ext cx="7818120" cy="1170432"/>
+            <a:off x="457200" y="1874519"/>
+            <a:ext cx="3657600" cy="1051560"/>
           </a:xfrm>
           <a:prstGeom prst="roundRect">
             <a:avLst>
@@ -4437,118 +4471,41 @@
           </a:fontRef>
         </p:style>
         <p:txBody>
-          <a:bodyPr rtlCol="0" anchor="ctr"/>
+          <a:bodyPr rtlCol="0" anchor="ctr" wrap="square" lIns="146304" tIns="91440"/>
           <a:lstStyle/>
           <a:p>
             <a:pPr algn="ctr"/>
-          </a:p>
-        </p:txBody>
-      </p:sp>
-      <p:sp>
-        <p:nvSpPr>
-          <p:cNvPr id="6" name="Oval 5"/>
+            <a:r>
+              <a:rPr sz="1100" b="1">
+                <a:solidFill>
+                  <a:srgbClr val="0D5C2C"/>
+                </a:solidFill>
+              </a:rPr>
+              <a:t>HOY</a:t>
+            </a:r>
+          </a:p>
+          <a:p>
+            <a:r>
+              <a:rPr sz="2000" b="1">
+                <a:solidFill>
+                  <a:srgbClr val="083A1C"/>
+                </a:solidFill>
+              </a:rPr>
+              <a:t>6 vacas</a:t>
+            </a:r>
+          </a:p>
+        </p:txBody>
+      </p:sp>
+      <p:sp>
+        <p:nvSpPr>
+          <p:cNvPr id="7" name="Rounded Rectangle 6"/>
           <p:cNvSpPr/>
           <p:nvPr/>
         </p:nvSpPr>
         <p:spPr>
           <a:xfrm>
-            <a:off x="621792" y="2002536"/>
-            <a:ext cx="530352" cy="530352"/>
-          </a:xfrm>
-          <a:prstGeom prst="ellipse">
-            <a:avLst/>
-          </a:prstGeom>
-          <a:solidFill>
-            <a:srgbClr val="0D5C2C"/>
-          </a:solidFill>
-          <a:ln>
-            <a:noFill/>
-          </a:ln>
-        </p:spPr>
-        <p:style>
-          <a:lnRef idx="1">
-            <a:schemeClr val="accent1"/>
-          </a:lnRef>
-          <a:fillRef idx="3">
-            <a:schemeClr val="accent1"/>
-          </a:fillRef>
-          <a:effectRef idx="2">
-            <a:schemeClr val="accent1"/>
-          </a:effectRef>
-          <a:fontRef idx="minor">
-            <a:schemeClr val="lt1"/>
-          </a:fontRef>
-        </p:style>
-        <p:txBody>
-          <a:bodyPr rtlCol="0" anchor="ctr"/>
-          <a:lstStyle/>
-          <a:p>
-            <a:pPr algn="ctr"/>
-            <a:r>
-              <a:rPr sz="1600" b="1">
-                <a:solidFill>
-                  <a:srgbClr val="FFFFFF"/>
-                </a:solidFill>
-              </a:rPr>
-              <a:t>1</a:t>
-            </a:r>
-          </a:p>
-        </p:txBody>
-      </p:sp>
-      <p:sp>
-        <p:nvSpPr>
-          <p:cNvPr id="7" name="TextBox 6"/>
-          <p:cNvSpPr txBox="1"/>
-          <p:nvPr/>
-        </p:nvSpPr>
-        <p:spPr>
-          <a:xfrm>
-            <a:off x="1325880" y="1801368"/>
-            <a:ext cx="6766560" cy="987552"/>
-          </a:xfrm>
-          <a:prstGeom prst="rect">
-            <a:avLst/>
-          </a:prstGeom>
-          <a:noFill/>
-        </p:spPr>
-        <p:txBody>
-          <a:bodyPr wrap="square">
-            <a:spAutoFit/>
-          </a:bodyPr>
-          <a:lstStyle/>
-          <a:p>
-            <a:r>
-              <a:rPr sz="1800" b="1">
-                <a:solidFill>
-                  <a:srgbClr val="0D5C2C"/>
-                </a:solidFill>
-              </a:rPr>
-              <a:t>Las 4 esquinas</a:t>
-            </a:r>
-          </a:p>
-          <a:p>
-            <a:r>
-              <a:rPr sz="1300">
-                <a:solidFill>
-                  <a:srgbClr val="2D2016"/>
-                </a:solidFill>
-              </a:rPr>
-              <a:t>Plano de mensura: latitud Sur y longitud Oeste (φ y λ).
-No use X e Y. Si hay 2 vértices, el resto se toca en el satélite.</a:t>
-            </a:r>
-          </a:p>
-        </p:txBody>
-      </p:sp>
-      <p:sp>
-        <p:nvSpPr>
-          <p:cNvPr id="8" name="Rounded Rectangle 7"/>
-          <p:cNvSpPr/>
-          <p:nvPr/>
-        </p:nvSpPr>
-        <p:spPr>
-          <a:xfrm>
-            <a:off x="457200" y="2990088"/>
-            <a:ext cx="7818120" cy="1170432"/>
+            <a:off x="4297680" y="1874519"/>
+            <a:ext cx="3657600" cy="1051560"/>
           </a:xfrm>
           <a:prstGeom prst="roundRect">
             <a:avLst>
@@ -4579,118 +4536,41 @@
           </a:fontRef>
         </p:style>
         <p:txBody>
-          <a:bodyPr rtlCol="0" anchor="ctr"/>
+          <a:bodyPr rtlCol="0" anchor="ctr" wrap="square" lIns="146304" tIns="91440"/>
           <a:lstStyle/>
           <a:p>
             <a:pPr algn="ctr"/>
-          </a:p>
-        </p:txBody>
-      </p:sp>
-      <p:sp>
-        <p:nvSpPr>
-          <p:cNvPr id="9" name="Oval 8"/>
+            <a:r>
+              <a:rPr sz="1100" b="1">
+                <a:solidFill>
+                  <a:srgbClr val="0D5C2C"/>
+                </a:solidFill>
+              </a:rPr>
+              <a:t>EL SUELO CUBRE EL AÑO</a:t>
+            </a:r>
+          </a:p>
+          <a:p>
+            <a:r>
+              <a:rPr sz="2000" b="1">
+                <a:solidFill>
+                  <a:srgbClr val="083A1C"/>
+                </a:solidFill>
+              </a:rPr>
+              <a:t>5 en año seco</a:t>
+            </a:r>
+          </a:p>
+        </p:txBody>
+      </p:sp>
+      <p:sp>
+        <p:nvSpPr>
+          <p:cNvPr id="8" name="Rounded Rectangle 7"/>
           <p:cNvSpPr/>
           <p:nvPr/>
         </p:nvSpPr>
         <p:spPr>
           <a:xfrm>
-            <a:off x="621792" y="3300984"/>
-            <a:ext cx="530352" cy="530352"/>
-          </a:xfrm>
-          <a:prstGeom prst="ellipse">
-            <a:avLst/>
-          </a:prstGeom>
-          <a:solidFill>
-            <a:srgbClr val="0D5C2C"/>
-          </a:solidFill>
-          <a:ln>
-            <a:noFill/>
-          </a:ln>
-        </p:spPr>
-        <p:style>
-          <a:lnRef idx="1">
-            <a:schemeClr val="accent1"/>
-          </a:lnRef>
-          <a:fillRef idx="3">
-            <a:schemeClr val="accent1"/>
-          </a:fillRef>
-          <a:effectRef idx="2">
-            <a:schemeClr val="accent1"/>
-          </a:effectRef>
-          <a:fontRef idx="minor">
-            <a:schemeClr val="lt1"/>
-          </a:fontRef>
-        </p:style>
-        <p:txBody>
-          <a:bodyPr rtlCol="0" anchor="ctr"/>
-          <a:lstStyle/>
-          <a:p>
-            <a:pPr algn="ctr"/>
-            <a:r>
-              <a:rPr sz="1600" b="1">
-                <a:solidFill>
-                  <a:srgbClr val="FFFFFF"/>
-                </a:solidFill>
-              </a:rPr>
-              <a:t>2</a:t>
-            </a:r>
-          </a:p>
-        </p:txBody>
-      </p:sp>
-      <p:sp>
-        <p:nvSpPr>
-          <p:cNvPr id="10" name="TextBox 9"/>
-          <p:cNvSpPr txBox="1"/>
-          <p:nvPr/>
-        </p:nvSpPr>
-        <p:spPr>
-          <a:xfrm>
-            <a:off x="1325880" y="3099816"/>
-            <a:ext cx="6766560" cy="987552"/>
-          </a:xfrm>
-          <a:prstGeom prst="rect">
-            <a:avLst/>
-          </a:prstGeom>
-          <a:noFill/>
-        </p:spPr>
-        <p:txBody>
-          <a:bodyPr wrap="square">
-            <a:spAutoFit/>
-          </a:bodyPr>
-          <a:lstStyle/>
-          <a:p>
-            <a:r>
-              <a:rPr sz="1800" b="1">
-                <a:solidFill>
-                  <a:srgbClr val="0D5C2C"/>
-                </a:solidFill>
-              </a:rPr>
-              <a:t>Las aguadas</a:t>
-            </a:r>
-          </a:p>
-          <a:p>
-            <a:r>
-              <a:rPr sz="1300">
-                <a:solidFill>
-                  <a:srgbClr val="2D2016"/>
-                </a:solidFill>
-              </a:rPr>
-              <a:t>Toque cada represa, molino o bebedero. Si se equivoca, toque la gota y Quitar.
-400 m cría · 800 m adulta. No se recorta bebida.</a:t>
-            </a:r>
-          </a:p>
-        </p:txBody>
-      </p:sp>
-      <p:sp>
-        <p:nvSpPr>
-          <p:cNvPr id="11" name="Rounded Rectangle 10"/>
-          <p:cNvSpPr/>
-          <p:nvPr/>
-        </p:nvSpPr>
-        <p:spPr>
-          <a:xfrm>
-            <a:off x="457200" y="4288536"/>
-            <a:ext cx="7818120" cy="1170432"/>
+            <a:off x="8138160" y="1874519"/>
+            <a:ext cx="3657600" cy="1051560"/>
           </a:xfrm>
           <a:prstGeom prst="roundRect">
             <a:avLst>
@@ -4721,118 +4601,41 @@
           </a:fontRef>
         </p:style>
         <p:txBody>
-          <a:bodyPr rtlCol="0" anchor="ctr"/>
+          <a:bodyPr rtlCol="0" anchor="ctr" wrap="square" lIns="146304" tIns="91440"/>
           <a:lstStyle/>
           <a:p>
             <a:pPr algn="ctr"/>
-          </a:p>
-        </p:txBody>
-      </p:sp>
-      <p:sp>
-        <p:nvSpPr>
-          <p:cNvPr id="12" name="Oval 11"/>
+            <a:r>
+              <a:rPr sz="1100" b="1">
+                <a:solidFill>
+                  <a:srgbClr val="0D5C2C"/>
+                </a:solidFill>
+              </a:rPr>
+              <a:t>DECISIÓN</a:t>
+            </a:r>
+          </a:p>
+          <a:p>
+            <a:r>
+              <a:rPr sz="2000" b="1">
+                <a:solidFill>
+                  <a:srgbClr val="083A1C"/>
+                </a:solidFill>
+              </a:rPr>
+              <a:t>Bajar 1  o diferido</a:t>
+            </a:r>
+          </a:p>
+        </p:txBody>
+      </p:sp>
+      <p:sp>
+        <p:nvSpPr>
+          <p:cNvPr id="9" name="Rounded Rectangle 8"/>
           <p:cNvSpPr/>
           <p:nvPr/>
         </p:nvSpPr>
         <p:spPr>
           <a:xfrm>
-            <a:off x="621792" y="4599431"/>
-            <a:ext cx="530352" cy="530352"/>
-          </a:xfrm>
-          <a:prstGeom prst="ellipse">
-            <a:avLst/>
-          </a:prstGeom>
-          <a:solidFill>
-            <a:srgbClr val="0D5C2C"/>
-          </a:solidFill>
-          <a:ln>
-            <a:noFill/>
-          </a:ln>
-        </p:spPr>
-        <p:style>
-          <a:lnRef idx="1">
-            <a:schemeClr val="accent1"/>
-          </a:lnRef>
-          <a:fillRef idx="3">
-            <a:schemeClr val="accent1"/>
-          </a:fillRef>
-          <a:effectRef idx="2">
-            <a:schemeClr val="accent1"/>
-          </a:effectRef>
-          <a:fontRef idx="minor">
-            <a:schemeClr val="lt1"/>
-          </a:fontRef>
-        </p:style>
-        <p:txBody>
-          <a:bodyPr rtlCol="0" anchor="ctr"/>
-          <a:lstStyle/>
-          <a:p>
-            <a:pPr algn="ctr"/>
-            <a:r>
-              <a:rPr sz="1600" b="1">
-                <a:solidFill>
-                  <a:srgbClr val="FFFFFF"/>
-                </a:solidFill>
-              </a:rPr>
-              <a:t>3</a:t>
-            </a:r>
-          </a:p>
-        </p:txBody>
-      </p:sp>
-      <p:sp>
-        <p:nvSpPr>
-          <p:cNvPr id="13" name="TextBox 12"/>
-          <p:cNvSpPr txBox="1"/>
-          <p:nvPr/>
-        </p:nvSpPr>
-        <p:spPr>
-          <a:xfrm>
-            <a:off x="1325880" y="4398264"/>
-            <a:ext cx="6766560" cy="987552"/>
-          </a:xfrm>
-          <a:prstGeom prst="rect">
-            <a:avLst/>
-          </a:prstGeom>
-          <a:noFill/>
-        </p:spPr>
-        <p:txBody>
-          <a:bodyPr wrap="square">
-            <a:spAutoFit/>
-          </a:bodyPr>
-          <a:lstStyle/>
-          <a:p>
-            <a:r>
-              <a:rPr sz="1800" b="1">
-                <a:solidFill>
-                  <a:srgbClr val="0D5C2C"/>
-                </a:solidFill>
-              </a:rPr>
-              <a:t>El informe</a:t>
-            </a:r>
-          </a:p>
-          <a:p>
-            <a:r>
-              <a:rPr sz="1300">
-                <a:solidFill>
-                  <a:srgbClr val="2D2016"/>
-                </a:solidFill>
-              </a:rPr>
-              <a:t>Puntos críticos: corto plazo (sin plata) y mediano (con agua).
-En el celular se ve igual; el campo no queda guardado.</a:t>
-            </a:r>
-          </a:p>
-        </p:txBody>
-      </p:sp>
-      <p:sp>
-        <p:nvSpPr>
-          <p:cNvPr id="14" name="Rounded Rectangle 13"/>
-          <p:cNvSpPr/>
-          <p:nvPr/>
-        </p:nvSpPr>
-        <p:spPr>
-          <a:xfrm>
-            <a:off x="8458200" y="1691640"/>
-            <a:ext cx="3291840" cy="3703320"/>
+            <a:off x="457200" y="3154680"/>
+            <a:ext cx="5623560" cy="932688"/>
           </a:xfrm>
           <a:prstGeom prst="roundRect">
             <a:avLst>
@@ -4863,123 +4666,232 @@
           </a:fontRef>
         </p:style>
         <p:txBody>
-          <a:bodyPr rtlCol="0" anchor="ctr" wrap="square" lIns="164592" tIns="146304"/>
+          <a:bodyPr rtlCol="0" anchor="ctr" wrap="square" lIns="164592" tIns="201168"/>
           <a:lstStyle/>
           <a:p>
             <a:pPr algn="ctr"/>
             <a:r>
-              <a:rPr sz="1300" b="1">
+              <a:rPr sz="1800" b="1">
                 <a:solidFill>
                   <a:srgbClr val="0D5C2C"/>
                 </a:solidFill>
               </a:rPr>
-              <a:t>Para recordar</a:t>
-            </a:r>
-          </a:p>
-          <a:p>
-            <a:pPr>
-              <a:spcBef>
-                <a:spcPts val="800"/>
-              </a:spcBef>
-            </a:pPr>
-            <a:r>
-              <a:rPr sz="1200">
-                <a:solidFill>
-                  <a:srgbClr val="2D2016"/>
+              <a:t>Bajar carga o no subir</a:t>
+            </a:r>
+          </a:p>
+        </p:txBody>
+      </p:sp>
+      <p:sp>
+        <p:nvSpPr>
+          <p:cNvPr id="10" name="Rounded Rectangle 9"/>
+          <p:cNvSpPr/>
+          <p:nvPr/>
+        </p:nvSpPr>
+        <p:spPr>
+          <a:xfrm>
+            <a:off x="6263640" y="3154680"/>
+            <a:ext cx="5623560" cy="932688"/>
+          </a:xfrm>
+          <a:prstGeom prst="roundRect">
+            <a:avLst>
+              <a:gd name="adj" fmla="val 8000"/>
+            </a:avLst>
+          </a:prstGeom>
+          <a:solidFill>
+            <a:srgbClr val="F7F1E4"/>
+          </a:solidFill>
+          <a:ln w="15875">
+            <a:solidFill>
+              <a:srgbClr val="C4A35A"/>
+            </a:solidFill>
+          </a:ln>
+        </p:spPr>
+        <p:style>
+          <a:lnRef idx="1">
+            <a:schemeClr val="accent1"/>
+          </a:lnRef>
+          <a:fillRef idx="3">
+            <a:schemeClr val="accent1"/>
+          </a:fillRef>
+          <a:effectRef idx="2">
+            <a:schemeClr val="accent1"/>
+          </a:effectRef>
+          <a:fontRef idx="minor">
+            <a:schemeClr val="lt1"/>
+          </a:fontRef>
+        </p:style>
+        <p:txBody>
+          <a:bodyPr rtlCol="0" anchor="ctr" wrap="square" lIns="164592" tIns="201168"/>
+          <a:lstStyle/>
+          <a:p>
+            <a:pPr algn="ctr"/>
+            <a:r>
+              <a:rPr sz="1800" b="1">
+                <a:solidFill>
+                  <a:srgbClr val="0D5C2C"/>
                 </a:solidFill>
               </a:rPr>
-              <a:t>▸ Capas: satélite, suelos INTA, OTBN.</a:t>
-            </a:r>
-          </a:p>
-          <a:p>
-            <a:pPr>
-              <a:spcBef>
-                <a:spcPts val="800"/>
-              </a:spcBef>
-            </a:pPr>
-            <a:r>
-              <a:rPr sz="1200">
-                <a:solidFill>
-                  <a:srgbClr val="2D2016"/>
+              <a:t>Rotar · dividir el cuadro</a:t>
+            </a:r>
+          </a:p>
+        </p:txBody>
+      </p:sp>
+      <p:sp>
+        <p:nvSpPr>
+          <p:cNvPr id="11" name="Rounded Rectangle 10"/>
+          <p:cNvSpPr/>
+          <p:nvPr/>
+        </p:nvSpPr>
+        <p:spPr>
+          <a:xfrm>
+            <a:off x="457200" y="4206240"/>
+            <a:ext cx="5623560" cy="932688"/>
+          </a:xfrm>
+          <a:prstGeom prst="roundRect">
+            <a:avLst>
+              <a:gd name="adj" fmla="val 8000"/>
+            </a:avLst>
+          </a:prstGeom>
+          <a:solidFill>
+            <a:srgbClr val="F7F1E4"/>
+          </a:solidFill>
+          <a:ln w="15875">
+            <a:solidFill>
+              <a:srgbClr val="C4A35A"/>
+            </a:solidFill>
+          </a:ln>
+        </p:spPr>
+        <p:style>
+          <a:lnRef idx="1">
+            <a:schemeClr val="accent1"/>
+          </a:lnRef>
+          <a:fillRef idx="3">
+            <a:schemeClr val="accent1"/>
+          </a:fillRef>
+          <a:effectRef idx="2">
+            <a:schemeClr val="accent1"/>
+          </a:effectRef>
+          <a:fontRef idx="minor">
+            <a:schemeClr val="lt1"/>
+          </a:fontRef>
+        </p:style>
+        <p:txBody>
+          <a:bodyPr rtlCol="0" anchor="ctr" wrap="square" lIns="164592" tIns="201168"/>
+          <a:lstStyle/>
+          <a:p>
+            <a:pPr algn="ctr"/>
+            <a:r>
+              <a:rPr sz="1800" b="1">
+                <a:solidFill>
+                  <a:srgbClr val="0D5C2C"/>
                 </a:solidFill>
               </a:rPr>
-              <a:t>▸ Manejo: Actual / M1 / Óptimo.</a:t>
-            </a:r>
-          </a:p>
-          <a:p>
-            <a:pPr>
-              <a:spcBef>
-                <a:spcPts val="800"/>
-              </a:spcBef>
-            </a:pPr>
-            <a:r>
-              <a:rPr sz="1200">
-                <a:solidFill>
-                  <a:srgbClr val="2D2016"/>
+              <a:t>Acercar aguada (si &gt; 400 m)</a:t>
+            </a:r>
+          </a:p>
+        </p:txBody>
+      </p:sp>
+      <p:sp>
+        <p:nvSpPr>
+          <p:cNvPr id="12" name="Rounded Rectangle 11"/>
+          <p:cNvSpPr/>
+          <p:nvPr/>
+        </p:nvSpPr>
+        <p:spPr>
+          <a:xfrm>
+            <a:off x="6263640" y="4206240"/>
+            <a:ext cx="5623560" cy="932688"/>
+          </a:xfrm>
+          <a:prstGeom prst="roundRect">
+            <a:avLst>
+              <a:gd name="adj" fmla="val 8000"/>
+            </a:avLst>
+          </a:prstGeom>
+          <a:solidFill>
+            <a:srgbClr val="F7F1E4"/>
+          </a:solidFill>
+          <a:ln w="15875">
+            <a:solidFill>
+              <a:srgbClr val="C4A35A"/>
+            </a:solidFill>
+          </a:ln>
+        </p:spPr>
+        <p:style>
+          <a:lnRef idx="1">
+            <a:schemeClr val="accent1"/>
+          </a:lnRef>
+          <a:fillRef idx="3">
+            <a:schemeClr val="accent1"/>
+          </a:fillRef>
+          <a:effectRef idx="2">
+            <a:schemeClr val="accent1"/>
+          </a:effectRef>
+          <a:fontRef idx="minor">
+            <a:schemeClr val="lt1"/>
+          </a:fontRef>
+        </p:style>
+        <p:txBody>
+          <a:bodyPr rtlCol="0" anchor="ctr" wrap="square" lIns="164592" tIns="201168"/>
+          <a:lstStyle/>
+          <a:p>
+            <a:pPr algn="ctr"/>
+            <a:r>
+              <a:rPr sz="1800" b="1">
+                <a:solidFill>
+                  <a:srgbClr val="0D5C2C"/>
                 </a:solidFill>
               </a:rPr>
-              <a:t>▸ IA: interfaz, no el núcleo.</a:t>
-            </a:r>
-          </a:p>
-          <a:p>
-            <a:pPr>
-              <a:spcBef>
-                <a:spcPts val="800"/>
-              </a:spcBef>
-            </a:pPr>
-            <a:r>
-              <a:rPr sz="1200">
-                <a:solidFill>
-                  <a:srgbClr val="2D2016"/>
-                </a:solidFill>
+              <a:t>Sembrar 1–2 ha de diferido</a:t>
+            </a:r>
+          </a:p>
+        </p:txBody>
+      </p:sp>
+      <p:sp>
+        <p:nvSpPr>
+          <p:cNvPr id="13" name="TextBox 12"/>
+          <p:cNvSpPr txBox="1"/>
+          <p:nvPr/>
+        </p:nvSpPr>
+        <p:spPr>
+          <a:xfrm>
+            <a:off x="457200" y="5349240"/>
+            <a:ext cx="11155680" cy="640080"/>
+          </a:xfrm>
+          <a:prstGeom prst="rect">
+            <a:avLst/>
+          </a:prstGeom>
+          <a:noFill/>
+        </p:spPr>
+        <p:txBody>
+          <a:bodyPr wrap="square">
+            <a:spAutoFit/>
+          </a:bodyPr>
+          <a:lstStyle/>
+          <a:p>
+            <a:r>
+              <a:rPr sz="1500">
+                <a:solidFill>
+                  <a:srgbClr val="C4A35A"/>
+                </a:solidFill>
+                <a:latin typeface="Calibri"/>
               </a:rPr>
-              <a:t>▸ Demostrativo ≠ su padrón.</a:t>
-            </a:r>
-          </a:p>
-          <a:p>
-            <a:pPr>
-              <a:spcBef>
-                <a:spcPts val="800"/>
-              </a:spcBef>
-            </a:pPr>
-            <a:r>
-              <a:rPr sz="1200">
-                <a:solidFill>
-                  <a:srgbClr val="2D2016"/>
-                </a:solidFill>
-              </a:rPr>
-              <a:t>▸ Computadora: se puede guardar.</a:t>
-            </a:r>
-          </a:p>
-          <a:p>
-            <a:pPr>
-              <a:spcBef>
-                <a:spcPts val="800"/>
-              </a:spcBef>
-            </a:pPr>
-            <a:r>
-              <a:rPr sz="1200">
-                <a:solidFill>
-                  <a:srgbClr val="2D2016"/>
-                </a:solidFill>
-              </a:rPr>
-              <a:t>▸ Celular: vista rápida, no guarda.</a:t>
-            </a:r>
-          </a:p>
-        </p:txBody>
-      </p:sp>
-      <p:sp>
-        <p:nvSpPr>
-          <p:cNvPr id="15" name="Rounded Rectangle 14">
-            <a:hlinkClick r:id="rId3"/>
+              <a:t>El cuello de botella es el invierno. Inversión mínima. OTBN I: no sembrar ni desmontar. El monte se usa, no se saca.</a:t>
+            </a:r>
+          </a:p>
+        </p:txBody>
+      </p:sp>
+      <p:sp>
+        <p:nvSpPr>
+          <p:cNvPr id="14" name="Rounded Rectangle 13">
+            <a:hlinkClick action="ppaction://hlinksldjump" r:id="rId4"/>
           </p:cNvPr>
           <p:cNvSpPr/>
           <p:nvPr/>
         </p:nvSpPr>
         <p:spPr>
           <a:xfrm>
-            <a:off x="8458200" y="5532120"/>
-            <a:ext cx="3291840" cy="438912"/>
+            <a:off x="457200" y="6327648"/>
+            <a:ext cx="1234440" cy="347472"/>
           </a:xfrm>
           <a:prstGeom prst="roundRect">
             <a:avLst>
@@ -5023,22 +4935,22 @@
                 </a:solidFill>
                 <a:latin typeface="Calibri"/>
               </a:rPr>
-              <a:t>Abrir el gemelo</a:t>
-            </a:r>
-          </a:p>
-        </p:txBody>
-      </p:sp>
-      <p:sp>
-        <p:nvSpPr>
-          <p:cNvPr id="16" name="Rounded Rectangle 15">
-            <a:hlinkClick action="ppaction://hlinksldjump" r:id="rId4"/>
+              <a:t>←  Atrás</a:t>
+            </a:r>
+          </a:p>
+        </p:txBody>
+      </p:sp>
+      <p:sp>
+        <p:nvSpPr>
+          <p:cNvPr id="15" name="Rounded Rectangle 14">
+            <a:hlinkClick action="ppaction://hlinksldjump" r:id="rId3"/>
           </p:cNvPr>
           <p:cNvSpPr/>
           <p:nvPr/>
         </p:nvSpPr>
         <p:spPr>
           <a:xfrm>
-            <a:off x="457200" y="6327648"/>
+            <a:off x="10515600" y="6327648"/>
             <a:ext cx="1234440" cy="347472"/>
           </a:xfrm>
           <a:prstGeom prst="roundRect">
@@ -5083,7 +4995,7 @@
                 </a:solidFill>
                 <a:latin typeface="Calibri"/>
               </a:rPr>
-              <a:t>←  Atrás</a:t>
+              <a:t>Siguiente  →</a:t>
             </a:r>
           </a:p>
         </p:txBody>
@@ -5212,6 +5124,1363 @@
                                     <p:set>
                                       <p:cBhvr>
                                         <p:cTn id="53" dur="1" fill="hold">
+                                          <p:stCondLst>
+                                            <p:cond delay="0"/>
+                                          </p:stCondLst>
+                                        </p:cTn>
+                                        <p:tgtEl>
+                                          <p:spTgt spid="None"/>
+                                        </p:tgtEl>
+                                        <p:attrNameLst>
+                                          <p:attrName>style.visibility</p:attrName>
+                                        </p:attrNameLst>
+                                      </p:cBhvr>
+                                      <p:to>
+                                        <p:strVal val="visible"/>
+                                      </p:to>
+                                    </p:set>
+                                  </p:childTnLst>
+                                </p:cTn>
+                              </p:par>
+                            </p:childTnLst>
+                          </p:cTn>
+                        </p:par>
+                      </p:childTnLst>
+                    </p:cTn>
+                  </p:par>
+                  <p:par>
+                    <p:cTn id="60" fill="hold">
+                      <p:stCondLst>
+                        <p:cond delay="indefinite"/>
+                      </p:stCondLst>
+                      <p:childTnLst>
+                        <p:par>
+                          <p:cTn id="61" fill="hold">
+                            <p:stCondLst>
+                              <p:cond delay="0"/>
+                            </p:stCondLst>
+                            <p:childTnLst>
+                              <p:par>
+                                <p:cTn id="62" presetID="1" presetClass="entr" presetSubtype="0" fill="hold" grpId="0" nodeType="clickEffect">
+                                  <p:stCondLst>
+                                    <p:cond delay="0"/>
+                                  </p:stCondLst>
+                                  <p:childTnLst>
+                                    <p:set>
+                                      <p:cBhvr>
+                                        <p:cTn id="63" dur="1" fill="hold">
+                                          <p:stCondLst>
+                                            <p:cond delay="0"/>
+                                          </p:stCondLst>
+                                        </p:cTn>
+                                        <p:tgtEl>
+                                          <p:spTgt spid="None"/>
+                                        </p:tgtEl>
+                                        <p:attrNameLst>
+                                          <p:attrName>style.visibility</p:attrName>
+                                        </p:attrNameLst>
+                                      </p:cBhvr>
+                                      <p:to>
+                                        <p:strVal val="visible"/>
+                                      </p:to>
+                                    </p:set>
+                                  </p:childTnLst>
+                                </p:cTn>
+                              </p:par>
+                            </p:childTnLst>
+                          </p:cTn>
+                        </p:par>
+                      </p:childTnLst>
+                    </p:cTn>
+                  </p:par>
+                  <p:par>
+                    <p:cTn id="70" fill="hold">
+                      <p:stCondLst>
+                        <p:cond delay="indefinite"/>
+                      </p:stCondLst>
+                      <p:childTnLst>
+                        <p:par>
+                          <p:cTn id="71" fill="hold">
+                            <p:stCondLst>
+                              <p:cond delay="0"/>
+                            </p:stCondLst>
+                            <p:childTnLst>
+                              <p:par>
+                                <p:cTn id="72" presetID="1" presetClass="entr" presetSubtype="0" fill="hold" grpId="0" nodeType="clickEffect">
+                                  <p:stCondLst>
+                                    <p:cond delay="0"/>
+                                  </p:stCondLst>
+                                  <p:childTnLst>
+                                    <p:set>
+                                      <p:cBhvr>
+                                        <p:cTn id="73" dur="1" fill="hold">
+                                          <p:stCondLst>
+                                            <p:cond delay="0"/>
+                                          </p:stCondLst>
+                                        </p:cTn>
+                                        <p:tgtEl>
+                                          <p:spTgt spid="None"/>
+                                        </p:tgtEl>
+                                        <p:attrNameLst>
+                                          <p:attrName>style.visibility</p:attrName>
+                                        </p:attrNameLst>
+                                      </p:cBhvr>
+                                      <p:to>
+                                        <p:strVal val="visible"/>
+                                      </p:to>
+                                    </p:set>
+                                  </p:childTnLst>
+                                </p:cTn>
+                              </p:par>
+                            </p:childTnLst>
+                          </p:cTn>
+                        </p:par>
+                      </p:childTnLst>
+                    </p:cTn>
+                  </p:par>
+                  <p:par>
+                    <p:cTn id="80" fill="hold">
+                      <p:stCondLst>
+                        <p:cond delay="indefinite"/>
+                      </p:stCondLst>
+                      <p:childTnLst>
+                        <p:par>
+                          <p:cTn id="81" fill="hold">
+                            <p:stCondLst>
+                              <p:cond delay="0"/>
+                            </p:stCondLst>
+                            <p:childTnLst>
+                              <p:par>
+                                <p:cTn id="82" presetID="1" presetClass="entr" presetSubtype="0" fill="hold" grpId="0" nodeType="clickEffect">
+                                  <p:stCondLst>
+                                    <p:cond delay="0"/>
+                                  </p:stCondLst>
+                                  <p:childTnLst>
+                                    <p:set>
+                                      <p:cBhvr>
+                                        <p:cTn id="83" dur="1" fill="hold">
+                                          <p:stCondLst>
+                                            <p:cond delay="0"/>
+                                          </p:stCondLst>
+                                        </p:cTn>
+                                        <p:tgtEl>
+                                          <p:spTgt spid="None"/>
+                                        </p:tgtEl>
+                                        <p:attrNameLst>
+                                          <p:attrName>style.visibility</p:attrName>
+                                        </p:attrNameLst>
+                                      </p:cBhvr>
+                                      <p:to>
+                                        <p:strVal val="visible"/>
+                                      </p:to>
+                                    </p:set>
+                                  </p:childTnLst>
+                                </p:cTn>
+                              </p:par>
+                            </p:childTnLst>
+                          </p:cTn>
+                        </p:par>
+                      </p:childTnLst>
+                    </p:cTn>
+                  </p:par>
+                  <p:par>
+                    <p:cTn id="90" fill="hold">
+                      <p:stCondLst>
+                        <p:cond delay="indefinite"/>
+                      </p:stCondLst>
+                      <p:childTnLst>
+                        <p:par>
+                          <p:cTn id="91" fill="hold">
+                            <p:stCondLst>
+                              <p:cond delay="0"/>
+                            </p:stCondLst>
+                            <p:childTnLst>
+                              <p:par>
+                                <p:cTn id="92" presetID="1" presetClass="entr" presetSubtype="0" fill="hold" grpId="0" nodeType="clickEffect">
+                                  <p:stCondLst>
+                                    <p:cond delay="0"/>
+                                  </p:stCondLst>
+                                  <p:childTnLst>
+                                    <p:set>
+                                      <p:cBhvr>
+                                        <p:cTn id="93" dur="1" fill="hold">
+                                          <p:stCondLst>
+                                            <p:cond delay="0"/>
+                                          </p:stCondLst>
+                                        </p:cTn>
+                                        <p:tgtEl>
+                                          <p:spTgt spid="None"/>
+                                        </p:tgtEl>
+                                        <p:attrNameLst>
+                                          <p:attrName>style.visibility</p:attrName>
+                                        </p:attrNameLst>
+                                      </p:cBhvr>
+                                      <p:to>
+                                        <p:strVal val="visible"/>
+                                      </p:to>
+                                    </p:set>
+                                  </p:childTnLst>
+                                </p:cTn>
+                              </p:par>
+                            </p:childTnLst>
+                          </p:cTn>
+                        </p:par>
+                      </p:childTnLst>
+                    </p:cTn>
+                  </p:par>
+                </p:childTnLst>
+              </p:cTn>
+              <p:prevCondLst>
+                <p:cond evt="onPrev" delay="0">
+                  <p:tgtEl>
+                    <p:sldTgt/>
+                  </p:tgtEl>
+                </p:cond>
+              </p:prevCondLst>
+              <p:nextCondLst>
+                <p:cond evt="onNext" delay="0">
+                  <p:tgtEl>
+                    <p:sldTgt/>
+                  </p:tgtEl>
+                </p:cond>
+              </p:nextCondLst>
+            </p:seq>
+          </p:childTnLst>
+        </p:cTn>
+      </p:par>
+    </p:tnLst>
+  </p:timing>
+</p:sld>
+</file>
+
+<file path=ppt/slides/slide4.xml><?xml version="1.0" encoding="utf-8"?>
+<p:sld xmlns:a="http://schemas.openxmlformats.org/drawingml/2006/main" xmlns:p="http://schemas.openxmlformats.org/presentationml/2006/main" xmlns:r="http://schemas.openxmlformats.org/officeDocument/2006/relationships">
+  <p:cSld>
+    <p:bg>
+      <p:bgPr>
+        <a:solidFill>
+          <a:srgbClr val="083A1C"/>
+        </a:solidFill>
+        <a:effectLst/>
+      </p:bgPr>
+    </p:bg>
+    <p:spTree>
+      <p:nvGrpSpPr>
+        <p:cNvPr id="1" name=""/>
+        <p:cNvGrpSpPr/>
+        <p:nvPr/>
+      </p:nvGrpSpPr>
+      <p:grpSpPr/>
+      <p:pic>
+        <p:nvPicPr>
+          <p:cNvPr id="2" name="Picture 1" descr="logo-sociedad-rural-san-luis.png"/>
+          <p:cNvPicPr>
+            <a:picLocks noChangeAspect="1"/>
+          </p:cNvPicPr>
+          <p:nvPr/>
+        </p:nvPicPr>
+        <p:blipFill>
+          <a:blip r:embed="rId2"/>
+          <a:stretch>
+            <a:fillRect/>
+          </a:stretch>
+        </p:blipFill>
+        <p:spPr>
+          <a:xfrm>
+            <a:off x="11292840" y="201168"/>
+            <a:ext cx="658368" cy="658368"/>
+          </a:xfrm>
+          <a:prstGeom prst="rect">
+            <a:avLst/>
+          </a:prstGeom>
+        </p:spPr>
+      </p:pic>
+      <p:sp>
+        <p:nvSpPr>
+          <p:cNvPr id="3" name="Rounded Rectangle 2"/>
+          <p:cNvSpPr/>
+          <p:nvPr/>
+        </p:nvSpPr>
+        <p:spPr>
+          <a:xfrm>
+            <a:off x="411480" y="256032"/>
+            <a:ext cx="6583680" cy="384048"/>
+          </a:xfrm>
+          <a:prstGeom prst="roundRect">
+            <a:avLst>
+              <a:gd name="adj" fmla="val 8000"/>
+            </a:avLst>
+          </a:prstGeom>
+          <a:solidFill>
+            <a:srgbClr val="083A1C"/>
+          </a:solidFill>
+          <a:ln>
+            <a:noFill/>
+          </a:ln>
+        </p:spPr>
+        <p:style>
+          <a:lnRef idx="1">
+            <a:schemeClr val="accent1"/>
+          </a:lnRef>
+          <a:fillRef idx="3">
+            <a:schemeClr val="accent1"/>
+          </a:fillRef>
+          <a:effectRef idx="2">
+            <a:schemeClr val="accent1"/>
+          </a:effectRef>
+          <a:fontRef idx="minor">
+            <a:schemeClr val="lt1"/>
+          </a:fontRef>
+        </p:style>
+        <p:txBody>
+          <a:bodyPr rtlCol="0" anchor="ctr" wrap="none"/>
+          <a:lstStyle/>
+          <a:p>
+            <a:pPr algn="ctr"/>
+            <a:r>
+              <a:rPr sz="1200" b="1">
+                <a:solidFill>
+                  <a:srgbClr val="C4A35A"/>
+                </a:solidFill>
+                <a:latin typeface="Calibri"/>
+              </a:rPr>
+              <a:t>CÓMO SE USA  ·  UNA VISITA AL PRODUCTOR</a:t>
+            </a:r>
+          </a:p>
+        </p:txBody>
+      </p:sp>
+      <p:sp>
+        <p:nvSpPr>
+          <p:cNvPr id="4" name="TextBox 3"/>
+          <p:cNvSpPr txBox="1"/>
+          <p:nvPr/>
+        </p:nvSpPr>
+        <p:spPr>
+          <a:xfrm>
+            <a:off x="457200" y="713232"/>
+            <a:ext cx="7498079" cy="1234440"/>
+          </a:xfrm>
+          <a:prstGeom prst="rect">
+            <a:avLst/>
+          </a:prstGeom>
+          <a:noFill/>
+        </p:spPr>
+        <p:txBody>
+          <a:bodyPr wrap="square">
+            <a:spAutoFit/>
+          </a:bodyPr>
+          <a:lstStyle/>
+          <a:p>
+            <a:r>
+              <a:rPr sz="4000" b="1">
+                <a:solidFill>
+                  <a:srgbClr val="FFFFFF"/>
+                </a:solidFill>
+                <a:latin typeface="Georgia"/>
+              </a:rPr>
+              <a:t>Cuatro pasos.</a:t>
+            </a:r>
+          </a:p>
+        </p:txBody>
+      </p:sp>
+      <p:sp>
+        <p:nvSpPr>
+          <p:cNvPr id="5" name="Rounded Rectangle 4"/>
+          <p:cNvSpPr/>
+          <p:nvPr/>
+        </p:nvSpPr>
+        <p:spPr>
+          <a:xfrm>
+            <a:off x="457200" y="1572768"/>
+            <a:ext cx="7818120" cy="960120"/>
+          </a:xfrm>
+          <a:prstGeom prst="roundRect">
+            <a:avLst>
+              <a:gd name="adj" fmla="val 8000"/>
+            </a:avLst>
+          </a:prstGeom>
+          <a:solidFill>
+            <a:srgbClr val="F7F1E4"/>
+          </a:solidFill>
+          <a:ln w="15875">
+            <a:solidFill>
+              <a:srgbClr val="C4A35A"/>
+            </a:solidFill>
+          </a:ln>
+        </p:spPr>
+        <p:style>
+          <a:lnRef idx="1">
+            <a:schemeClr val="accent1"/>
+          </a:lnRef>
+          <a:fillRef idx="3">
+            <a:schemeClr val="accent1"/>
+          </a:fillRef>
+          <a:effectRef idx="2">
+            <a:schemeClr val="accent1"/>
+          </a:effectRef>
+          <a:fontRef idx="minor">
+            <a:schemeClr val="lt1"/>
+          </a:fontRef>
+        </p:style>
+        <p:txBody>
+          <a:bodyPr rtlCol="0" anchor="ctr"/>
+          <a:lstStyle/>
+          <a:p>
+            <a:pPr algn="ctr"/>
+          </a:p>
+        </p:txBody>
+      </p:sp>
+      <p:sp>
+        <p:nvSpPr>
+          <p:cNvPr id="6" name="Oval 5"/>
+          <p:cNvSpPr/>
+          <p:nvPr/>
+        </p:nvSpPr>
+        <p:spPr>
+          <a:xfrm>
+            <a:off x="621792" y="1792224"/>
+            <a:ext cx="475488" cy="475488"/>
+          </a:xfrm>
+          <a:prstGeom prst="ellipse">
+            <a:avLst/>
+          </a:prstGeom>
+          <a:solidFill>
+            <a:srgbClr val="0D5C2C"/>
+          </a:solidFill>
+          <a:ln>
+            <a:noFill/>
+          </a:ln>
+        </p:spPr>
+        <p:style>
+          <a:lnRef idx="1">
+            <a:schemeClr val="accent1"/>
+          </a:lnRef>
+          <a:fillRef idx="3">
+            <a:schemeClr val="accent1"/>
+          </a:fillRef>
+          <a:effectRef idx="2">
+            <a:schemeClr val="accent1"/>
+          </a:effectRef>
+          <a:fontRef idx="minor">
+            <a:schemeClr val="lt1"/>
+          </a:fontRef>
+        </p:style>
+        <p:txBody>
+          <a:bodyPr rtlCol="0" anchor="ctr"/>
+          <a:lstStyle/>
+          <a:p>
+            <a:pPr algn="ctr"/>
+            <a:r>
+              <a:rPr sz="1500" b="1">
+                <a:solidFill>
+                  <a:srgbClr val="FFFFFF"/>
+                </a:solidFill>
+              </a:rPr>
+              <a:t>1</a:t>
+            </a:r>
+          </a:p>
+        </p:txBody>
+      </p:sp>
+      <p:sp>
+        <p:nvSpPr>
+          <p:cNvPr id="7" name="TextBox 6"/>
+          <p:cNvSpPr txBox="1"/>
+          <p:nvPr/>
+        </p:nvSpPr>
+        <p:spPr>
+          <a:xfrm>
+            <a:off x="1280160" y="1645920"/>
+            <a:ext cx="6812280" cy="822960"/>
+          </a:xfrm>
+          <a:prstGeom prst="rect">
+            <a:avLst/>
+          </a:prstGeom>
+          <a:noFill/>
+        </p:spPr>
+        <p:txBody>
+          <a:bodyPr wrap="square">
+            <a:spAutoFit/>
+          </a:bodyPr>
+          <a:lstStyle/>
+          <a:p>
+            <a:r>
+              <a:rPr sz="1700" b="1">
+                <a:solidFill>
+                  <a:srgbClr val="0D5C2C"/>
+                </a:solidFill>
+              </a:rPr>
+              <a:t>Las 4 esquinas</a:t>
+            </a:r>
+          </a:p>
+          <a:p>
+            <a:r>
+              <a:rPr sz="1200">
+                <a:solidFill>
+                  <a:srgbClr val="2D2016"/>
+                </a:solidFill>
+              </a:rPr>
+              <a:t>Plano de mensura: latitud Sur y longitud Oeste (φ y λ). No use X e Y.</a:t>
+            </a:r>
+          </a:p>
+        </p:txBody>
+      </p:sp>
+      <p:sp>
+        <p:nvSpPr>
+          <p:cNvPr id="8" name="Rounded Rectangle 7"/>
+          <p:cNvSpPr/>
+          <p:nvPr/>
+        </p:nvSpPr>
+        <p:spPr>
+          <a:xfrm>
+            <a:off x="457200" y="2596896"/>
+            <a:ext cx="7818120" cy="960120"/>
+          </a:xfrm>
+          <a:prstGeom prst="roundRect">
+            <a:avLst>
+              <a:gd name="adj" fmla="val 8000"/>
+            </a:avLst>
+          </a:prstGeom>
+          <a:solidFill>
+            <a:srgbClr val="F7F1E4"/>
+          </a:solidFill>
+          <a:ln w="15875">
+            <a:solidFill>
+              <a:srgbClr val="C4A35A"/>
+            </a:solidFill>
+          </a:ln>
+        </p:spPr>
+        <p:style>
+          <a:lnRef idx="1">
+            <a:schemeClr val="accent1"/>
+          </a:lnRef>
+          <a:fillRef idx="3">
+            <a:schemeClr val="accent1"/>
+          </a:fillRef>
+          <a:effectRef idx="2">
+            <a:schemeClr val="accent1"/>
+          </a:effectRef>
+          <a:fontRef idx="minor">
+            <a:schemeClr val="lt1"/>
+          </a:fontRef>
+        </p:style>
+        <p:txBody>
+          <a:bodyPr rtlCol="0" anchor="ctr"/>
+          <a:lstStyle/>
+          <a:p>
+            <a:pPr algn="ctr"/>
+          </a:p>
+        </p:txBody>
+      </p:sp>
+      <p:sp>
+        <p:nvSpPr>
+          <p:cNvPr id="9" name="Oval 8"/>
+          <p:cNvSpPr/>
+          <p:nvPr/>
+        </p:nvSpPr>
+        <p:spPr>
+          <a:xfrm>
+            <a:off x="621792" y="2816352"/>
+            <a:ext cx="475488" cy="475488"/>
+          </a:xfrm>
+          <a:prstGeom prst="ellipse">
+            <a:avLst/>
+          </a:prstGeom>
+          <a:solidFill>
+            <a:srgbClr val="0D5C2C"/>
+          </a:solidFill>
+          <a:ln>
+            <a:noFill/>
+          </a:ln>
+        </p:spPr>
+        <p:style>
+          <a:lnRef idx="1">
+            <a:schemeClr val="accent1"/>
+          </a:lnRef>
+          <a:fillRef idx="3">
+            <a:schemeClr val="accent1"/>
+          </a:fillRef>
+          <a:effectRef idx="2">
+            <a:schemeClr val="accent1"/>
+          </a:effectRef>
+          <a:fontRef idx="minor">
+            <a:schemeClr val="lt1"/>
+          </a:fontRef>
+        </p:style>
+        <p:txBody>
+          <a:bodyPr rtlCol="0" anchor="ctr"/>
+          <a:lstStyle/>
+          <a:p>
+            <a:pPr algn="ctr"/>
+            <a:r>
+              <a:rPr sz="1500" b="1">
+                <a:solidFill>
+                  <a:srgbClr val="FFFFFF"/>
+                </a:solidFill>
+              </a:rPr>
+              <a:t>2</a:t>
+            </a:r>
+          </a:p>
+        </p:txBody>
+      </p:sp>
+      <p:sp>
+        <p:nvSpPr>
+          <p:cNvPr id="10" name="TextBox 9"/>
+          <p:cNvSpPr txBox="1"/>
+          <p:nvPr/>
+        </p:nvSpPr>
+        <p:spPr>
+          <a:xfrm>
+            <a:off x="1280160" y="2670048"/>
+            <a:ext cx="6812280" cy="822960"/>
+          </a:xfrm>
+          <a:prstGeom prst="rect">
+            <a:avLst/>
+          </a:prstGeom>
+          <a:noFill/>
+        </p:spPr>
+        <p:txBody>
+          <a:bodyPr wrap="square">
+            <a:spAutoFit/>
+          </a:bodyPr>
+          <a:lstStyle/>
+          <a:p>
+            <a:r>
+              <a:rPr sz="1700" b="1">
+                <a:solidFill>
+                  <a:srgbClr val="0D5C2C"/>
+                </a:solidFill>
+              </a:rPr>
+              <a:t>Las aguadas</a:t>
+            </a:r>
+          </a:p>
+          <a:p>
+            <a:r>
+              <a:rPr sz="1200">
+                <a:solidFill>
+                  <a:srgbClr val="2D2016"/>
+                </a:solidFill>
+              </a:rPr>
+              <a:t>Toque cada represa o molino. 400 m cría · 800 m adulta. No se recorta bebida.</a:t>
+            </a:r>
+          </a:p>
+        </p:txBody>
+      </p:sp>
+      <p:sp>
+        <p:nvSpPr>
+          <p:cNvPr id="11" name="Rounded Rectangle 10"/>
+          <p:cNvSpPr/>
+          <p:nvPr/>
+        </p:nvSpPr>
+        <p:spPr>
+          <a:xfrm>
+            <a:off x="457200" y="3621024"/>
+            <a:ext cx="7818120" cy="960120"/>
+          </a:xfrm>
+          <a:prstGeom prst="roundRect">
+            <a:avLst>
+              <a:gd name="adj" fmla="val 8000"/>
+            </a:avLst>
+          </a:prstGeom>
+          <a:solidFill>
+            <a:srgbClr val="F7F1E4"/>
+          </a:solidFill>
+          <a:ln w="15875">
+            <a:solidFill>
+              <a:srgbClr val="C4A35A"/>
+            </a:solidFill>
+          </a:ln>
+        </p:spPr>
+        <p:style>
+          <a:lnRef idx="1">
+            <a:schemeClr val="accent1"/>
+          </a:lnRef>
+          <a:fillRef idx="3">
+            <a:schemeClr val="accent1"/>
+          </a:fillRef>
+          <a:effectRef idx="2">
+            <a:schemeClr val="accent1"/>
+          </a:effectRef>
+          <a:fontRef idx="minor">
+            <a:schemeClr val="lt1"/>
+          </a:fontRef>
+        </p:style>
+        <p:txBody>
+          <a:bodyPr rtlCol="0" anchor="ctr"/>
+          <a:lstStyle/>
+          <a:p>
+            <a:pPr algn="ctr"/>
+          </a:p>
+        </p:txBody>
+      </p:sp>
+      <p:sp>
+        <p:nvSpPr>
+          <p:cNvPr id="12" name="Oval 11"/>
+          <p:cNvSpPr/>
+          <p:nvPr/>
+        </p:nvSpPr>
+        <p:spPr>
+          <a:xfrm>
+            <a:off x="621792" y="3840480"/>
+            <a:ext cx="475488" cy="475488"/>
+          </a:xfrm>
+          <a:prstGeom prst="ellipse">
+            <a:avLst/>
+          </a:prstGeom>
+          <a:solidFill>
+            <a:srgbClr val="0D5C2C"/>
+          </a:solidFill>
+          <a:ln>
+            <a:noFill/>
+          </a:ln>
+        </p:spPr>
+        <p:style>
+          <a:lnRef idx="1">
+            <a:schemeClr val="accent1"/>
+          </a:lnRef>
+          <a:fillRef idx="3">
+            <a:schemeClr val="accent1"/>
+          </a:fillRef>
+          <a:effectRef idx="2">
+            <a:schemeClr val="accent1"/>
+          </a:effectRef>
+          <a:fontRef idx="minor">
+            <a:schemeClr val="lt1"/>
+          </a:fontRef>
+        </p:style>
+        <p:txBody>
+          <a:bodyPr rtlCol="0" anchor="ctr"/>
+          <a:lstStyle/>
+          <a:p>
+            <a:pPr algn="ctr"/>
+            <a:r>
+              <a:rPr sz="1500" b="1">
+                <a:solidFill>
+                  <a:srgbClr val="FFFFFF"/>
+                </a:solidFill>
+              </a:rPr>
+              <a:t>3</a:t>
+            </a:r>
+          </a:p>
+        </p:txBody>
+      </p:sp>
+      <p:sp>
+        <p:nvSpPr>
+          <p:cNvPr id="13" name="TextBox 12"/>
+          <p:cNvSpPr txBox="1"/>
+          <p:nvPr/>
+        </p:nvSpPr>
+        <p:spPr>
+          <a:xfrm>
+            <a:off x="1280160" y="3694176"/>
+            <a:ext cx="6812280" cy="822960"/>
+          </a:xfrm>
+          <a:prstGeom prst="rect">
+            <a:avLst/>
+          </a:prstGeom>
+          <a:noFill/>
+        </p:spPr>
+        <p:txBody>
+          <a:bodyPr wrap="square">
+            <a:spAutoFit/>
+          </a:bodyPr>
+          <a:lstStyle/>
+          <a:p>
+            <a:r>
+              <a:rPr sz="1700" b="1">
+                <a:solidFill>
+                  <a:srgbClr val="0D5C2C"/>
+                </a:solidFill>
+              </a:rPr>
+              <a:t>Manejo</a:t>
+            </a:r>
+          </a:p>
+          <a:p>
+            <a:r>
+              <a:rPr sz="1200">
+                <a:solidFill>
+                  <a:srgbClr val="2D2016"/>
+                </a:solidFill>
+              </a:rPr>
+              <a:t>Inicial, Mejorando e Ideal. El calendario dice hasta dónde subir y en qué mes actuar.</a:t>
+            </a:r>
+          </a:p>
+        </p:txBody>
+      </p:sp>
+      <p:sp>
+        <p:nvSpPr>
+          <p:cNvPr id="14" name="Rounded Rectangle 13"/>
+          <p:cNvSpPr/>
+          <p:nvPr/>
+        </p:nvSpPr>
+        <p:spPr>
+          <a:xfrm>
+            <a:off x="457200" y="4645152"/>
+            <a:ext cx="7818120" cy="960120"/>
+          </a:xfrm>
+          <a:prstGeom prst="roundRect">
+            <a:avLst>
+              <a:gd name="adj" fmla="val 8000"/>
+            </a:avLst>
+          </a:prstGeom>
+          <a:solidFill>
+            <a:srgbClr val="F7F1E4"/>
+          </a:solidFill>
+          <a:ln w="15875">
+            <a:solidFill>
+              <a:srgbClr val="C4A35A"/>
+            </a:solidFill>
+          </a:ln>
+        </p:spPr>
+        <p:style>
+          <a:lnRef idx="1">
+            <a:schemeClr val="accent1"/>
+          </a:lnRef>
+          <a:fillRef idx="3">
+            <a:schemeClr val="accent1"/>
+          </a:fillRef>
+          <a:effectRef idx="2">
+            <a:schemeClr val="accent1"/>
+          </a:effectRef>
+          <a:fontRef idx="minor">
+            <a:schemeClr val="lt1"/>
+          </a:fontRef>
+        </p:style>
+        <p:txBody>
+          <a:bodyPr rtlCol="0" anchor="ctr"/>
+          <a:lstStyle/>
+          <a:p>
+            <a:pPr algn="ctr"/>
+          </a:p>
+        </p:txBody>
+      </p:sp>
+      <p:sp>
+        <p:nvSpPr>
+          <p:cNvPr id="15" name="Oval 14"/>
+          <p:cNvSpPr/>
+          <p:nvPr/>
+        </p:nvSpPr>
+        <p:spPr>
+          <a:xfrm>
+            <a:off x="621792" y="4864608"/>
+            <a:ext cx="475488" cy="475488"/>
+          </a:xfrm>
+          <a:prstGeom prst="ellipse">
+            <a:avLst/>
+          </a:prstGeom>
+          <a:solidFill>
+            <a:srgbClr val="0D5C2C"/>
+          </a:solidFill>
+          <a:ln>
+            <a:noFill/>
+          </a:ln>
+        </p:spPr>
+        <p:style>
+          <a:lnRef idx="1">
+            <a:schemeClr val="accent1"/>
+          </a:lnRef>
+          <a:fillRef idx="3">
+            <a:schemeClr val="accent1"/>
+          </a:fillRef>
+          <a:effectRef idx="2">
+            <a:schemeClr val="accent1"/>
+          </a:effectRef>
+          <a:fontRef idx="minor">
+            <a:schemeClr val="lt1"/>
+          </a:fontRef>
+        </p:style>
+        <p:txBody>
+          <a:bodyPr rtlCol="0" anchor="ctr"/>
+          <a:lstStyle/>
+          <a:p>
+            <a:pPr algn="ctr"/>
+            <a:r>
+              <a:rPr sz="1500" b="1">
+                <a:solidFill>
+                  <a:srgbClr val="FFFFFF"/>
+                </a:solidFill>
+              </a:rPr>
+              <a:t>4</a:t>
+            </a:r>
+          </a:p>
+        </p:txBody>
+      </p:sp>
+      <p:sp>
+        <p:nvSpPr>
+          <p:cNvPr id="16" name="TextBox 15"/>
+          <p:cNvSpPr txBox="1"/>
+          <p:nvPr/>
+        </p:nvSpPr>
+        <p:spPr>
+          <a:xfrm>
+            <a:off x="1280160" y="4718304"/>
+            <a:ext cx="6812280" cy="822960"/>
+          </a:xfrm>
+          <a:prstGeom prst="rect">
+            <a:avLst/>
+          </a:prstGeom>
+          <a:noFill/>
+        </p:spPr>
+        <p:txBody>
+          <a:bodyPr wrap="square">
+            <a:spAutoFit/>
+          </a:bodyPr>
+          <a:lstStyle/>
+          <a:p>
+            <a:r>
+              <a:rPr sz="1700" b="1">
+                <a:solidFill>
+                  <a:srgbClr val="0D5C2C"/>
+                </a:solidFill>
+              </a:rPr>
+              <a:t>El informe</a:t>
+            </a:r>
+          </a:p>
+          <a:p>
+            <a:r>
+              <a:rPr sz="1200">
+                <a:solidFill>
+                  <a:srgbClr val="2D2016"/>
+                </a:solidFill>
+              </a:rPr>
+              <a:t>Puntos críticos. Corto y mediano plazo. En el celular se ve igual; no queda guardado.</a:t>
+            </a:r>
+          </a:p>
+        </p:txBody>
+      </p:sp>
+      <p:sp>
+        <p:nvSpPr>
+          <p:cNvPr id="17" name="Rounded Rectangle 16"/>
+          <p:cNvSpPr/>
+          <p:nvPr/>
+        </p:nvSpPr>
+        <p:spPr>
+          <a:xfrm>
+            <a:off x="8458200" y="1572768"/>
+            <a:ext cx="3291840" cy="3822191"/>
+          </a:xfrm>
+          <a:prstGeom prst="roundRect">
+            <a:avLst>
+              <a:gd name="adj" fmla="val 8000"/>
+            </a:avLst>
+          </a:prstGeom>
+          <a:solidFill>
+            <a:srgbClr val="F7F1E4"/>
+          </a:solidFill>
+          <a:ln w="15875">
+            <a:solidFill>
+              <a:srgbClr val="C4A35A"/>
+            </a:solidFill>
+          </a:ln>
+        </p:spPr>
+        <p:style>
+          <a:lnRef idx="1">
+            <a:schemeClr val="accent1"/>
+          </a:lnRef>
+          <a:fillRef idx="3">
+            <a:schemeClr val="accent1"/>
+          </a:fillRef>
+          <a:effectRef idx="2">
+            <a:schemeClr val="accent1"/>
+          </a:effectRef>
+          <a:fontRef idx="minor">
+            <a:schemeClr val="lt1"/>
+          </a:fontRef>
+        </p:style>
+        <p:txBody>
+          <a:bodyPr rtlCol="0" anchor="ctr" wrap="square" lIns="164592" tIns="146304"/>
+          <a:lstStyle/>
+          <a:p>
+            <a:pPr algn="ctr"/>
+            <a:r>
+              <a:rPr sz="1300" b="1">
+                <a:solidFill>
+                  <a:srgbClr val="0D5C2C"/>
+                </a:solidFill>
+              </a:rPr>
+              <a:t>Para recordar</a:t>
+            </a:r>
+          </a:p>
+          <a:p>
+            <a:pPr>
+              <a:spcBef>
+                <a:spcPts val="800"/>
+              </a:spcBef>
+            </a:pPr>
+            <a:r>
+              <a:rPr sz="1200">
+                <a:solidFill>
+                  <a:srgbClr val="2D2016"/>
+                </a:solidFill>
+              </a:rPr>
+              <a:t>▸ Capas: satélite, INTA, OTBN, lluvia, forraje.</a:t>
+            </a:r>
+          </a:p>
+          <a:p>
+            <a:pPr>
+              <a:spcBef>
+                <a:spcPts val="800"/>
+              </a:spcBef>
+            </a:pPr>
+            <a:r>
+              <a:rPr sz="1200">
+                <a:solidFill>
+                  <a:srgbClr val="2D2016"/>
+                </a:solidFill>
+              </a:rPr>
+              <a:t>▸ Manejo: Inicial / Mejorando / Ideal.</a:t>
+            </a:r>
+          </a:p>
+          <a:p>
+            <a:pPr>
+              <a:spcBef>
+                <a:spcPts val="800"/>
+              </a:spcBef>
+            </a:pPr>
+            <a:r>
+              <a:rPr sz="1200">
+                <a:solidFill>
+                  <a:srgbClr val="2D2016"/>
+                </a:solidFill>
+              </a:rPr>
+              <a:t>▸ Calendario: verde pasto, rojo actuar.</a:t>
+            </a:r>
+          </a:p>
+          <a:p>
+            <a:pPr>
+              <a:spcBef>
+                <a:spcPts val="800"/>
+              </a:spcBef>
+            </a:pPr>
+            <a:r>
+              <a:rPr sz="1200">
+                <a:solidFill>
+                  <a:srgbClr val="2D2016"/>
+                </a:solidFill>
+              </a:rPr>
+              <a:t>▸ IA: interfaz, no el núcleo.</a:t>
+            </a:r>
+          </a:p>
+          <a:p>
+            <a:pPr>
+              <a:spcBef>
+                <a:spcPts val="800"/>
+              </a:spcBef>
+            </a:pPr>
+            <a:r>
+              <a:rPr sz="1200">
+                <a:solidFill>
+                  <a:srgbClr val="2D2016"/>
+                </a:solidFill>
+              </a:rPr>
+              <a:t>▸ Computadora: se puede guardar.</a:t>
+            </a:r>
+          </a:p>
+          <a:p>
+            <a:pPr>
+              <a:spcBef>
+                <a:spcPts val="800"/>
+              </a:spcBef>
+            </a:pPr>
+            <a:r>
+              <a:rPr sz="1200">
+                <a:solidFill>
+                  <a:srgbClr val="2D2016"/>
+                </a:solidFill>
+              </a:rPr>
+              <a:t>▸ Celular: vista rápida, no guarda.</a:t>
+            </a:r>
+          </a:p>
+        </p:txBody>
+      </p:sp>
+      <p:sp>
+        <p:nvSpPr>
+          <p:cNvPr id="18" name="Rounded Rectangle 17">
+            <a:hlinkClick r:id="rId3"/>
+          </p:cNvPr>
+          <p:cNvSpPr/>
+          <p:nvPr/>
+        </p:nvSpPr>
+        <p:spPr>
+          <a:xfrm>
+            <a:off x="8458200" y="5532120"/>
+            <a:ext cx="3291840" cy="438912"/>
+          </a:xfrm>
+          <a:prstGeom prst="roundRect">
+            <a:avLst>
+              <a:gd name="adj" fmla="val 8000"/>
+            </a:avLst>
+          </a:prstGeom>
+          <a:solidFill>
+            <a:srgbClr val="C4A35A"/>
+          </a:solidFill>
+          <a:ln>
+            <a:noFill/>
+          </a:ln>
+        </p:spPr>
+        <p:style>
+          <a:lnRef idx="1">
+            <a:schemeClr val="accent1"/>
+          </a:lnRef>
+          <a:fillRef idx="3">
+            <a:schemeClr val="accent1"/>
+          </a:fillRef>
+          <a:effectRef idx="2">
+            <a:schemeClr val="accent1"/>
+          </a:effectRef>
+          <a:fontRef idx="minor">
+            <a:schemeClr val="lt1"/>
+          </a:fontRef>
+        </p:style>
+        <p:txBody>
+          <a:bodyPr rtlCol="0" anchor="ctr" wrap="none"/>
+          <a:lstStyle/>
+          <a:p>
+            <a:pPr algn="ctr">
+              <a:spcBef>
+                <a:spcPts val="0"/>
+              </a:spcBef>
+            </a:pPr>
+            <a:r>
+              <a:rPr sz="1200" b="1">
+                <a:solidFill>
+                  <a:srgbClr val="083A1C"/>
+                </a:solidFill>
+                <a:latin typeface="Calibri"/>
+              </a:rPr>
+              <a:t>Abrir el gemelo</a:t>
+            </a:r>
+          </a:p>
+        </p:txBody>
+      </p:sp>
+      <p:sp>
+        <p:nvSpPr>
+          <p:cNvPr id="19" name="Rounded Rectangle 18">
+            <a:hlinkClick action="ppaction://hlinksldjump" r:id="rId4"/>
+          </p:cNvPr>
+          <p:cNvSpPr/>
+          <p:nvPr/>
+        </p:nvSpPr>
+        <p:spPr>
+          <a:xfrm>
+            <a:off x="457200" y="6327648"/>
+            <a:ext cx="1234440" cy="347472"/>
+          </a:xfrm>
+          <a:prstGeom prst="roundRect">
+            <a:avLst>
+              <a:gd name="adj" fmla="val 8000"/>
+            </a:avLst>
+          </a:prstGeom>
+          <a:solidFill>
+            <a:srgbClr val="C4A35A"/>
+          </a:solidFill>
+          <a:ln>
+            <a:noFill/>
+          </a:ln>
+        </p:spPr>
+        <p:style>
+          <a:lnRef idx="1">
+            <a:schemeClr val="accent1"/>
+          </a:lnRef>
+          <a:fillRef idx="3">
+            <a:schemeClr val="accent1"/>
+          </a:fillRef>
+          <a:effectRef idx="2">
+            <a:schemeClr val="accent1"/>
+          </a:effectRef>
+          <a:fontRef idx="minor">
+            <a:schemeClr val="lt1"/>
+          </a:fontRef>
+        </p:style>
+        <p:txBody>
+          <a:bodyPr rtlCol="0" anchor="ctr" wrap="none"/>
+          <a:lstStyle/>
+          <a:p>
+            <a:pPr algn="ctr">
+              <a:spcBef>
+                <a:spcPts val="0"/>
+              </a:spcBef>
+            </a:pPr>
+            <a:r>
+              <a:rPr sz="1200" b="1">
+                <a:solidFill>
+                  <a:srgbClr val="083A1C"/>
+                </a:solidFill>
+                <a:latin typeface="Calibri"/>
+              </a:rPr>
+              <a:t>←  Atrás</a:t>
+            </a:r>
+          </a:p>
+        </p:txBody>
+      </p:sp>
+    </p:spTree>
+  </p:cSld>
+  <p:clrMapOvr>
+    <a:masterClrMapping/>
+  </p:clrMapOvr>
+  <p:timing>
+    <p:tnLst>
+      <p:par>
+        <p:cTn id="1" dur="indefinite" restart="never" nodeType="tmRoot">
+          <p:childTnLst>
+            <p:seq concurrent="1" nextAc="seek">
+              <p:cTn id="2" dur="indefinite" nodeType="mainSeq">
+                <p:childTnLst>
+                  <p:par>
+                    <p:cTn id="30" fill="hold">
+                      <p:stCondLst>
+                        <p:cond delay="indefinite"/>
+                      </p:stCondLst>
+                      <p:childTnLst>
+                        <p:par>
+                          <p:cTn id="31" fill="hold">
+                            <p:stCondLst>
+                              <p:cond delay="0"/>
+                            </p:stCondLst>
+                            <p:childTnLst>
+                              <p:par>
+                                <p:cTn id="32" presetID="1" presetClass="entr" presetSubtype="0" fill="hold" grpId="0" nodeType="clickEffect">
+                                  <p:stCondLst>
+                                    <p:cond delay="0"/>
+                                  </p:stCondLst>
+                                  <p:childTnLst>
+                                    <p:set>
+                                      <p:cBhvr>
+                                        <p:cTn id="33" dur="1" fill="hold">
+                                          <p:stCondLst>
+                                            <p:cond delay="0"/>
+                                          </p:stCondLst>
+                                        </p:cTn>
+                                        <p:tgtEl>
+                                          <p:spTgt spid="None"/>
+                                        </p:tgtEl>
+                                        <p:attrNameLst>
+                                          <p:attrName>style.visibility</p:attrName>
+                                        </p:attrNameLst>
+                                      </p:cBhvr>
+                                      <p:to>
+                                        <p:strVal val="visible"/>
+                                      </p:to>
+                                    </p:set>
+                                  </p:childTnLst>
+                                </p:cTn>
+                              </p:par>
+                            </p:childTnLst>
+                          </p:cTn>
+                        </p:par>
+                      </p:childTnLst>
+                    </p:cTn>
+                  </p:par>
+                  <p:par>
+                    <p:cTn id="40" fill="hold">
+                      <p:stCondLst>
+                        <p:cond delay="indefinite"/>
+                      </p:stCondLst>
+                      <p:childTnLst>
+                        <p:par>
+                          <p:cTn id="41" fill="hold">
+                            <p:stCondLst>
+                              <p:cond delay="0"/>
+                            </p:stCondLst>
+                            <p:childTnLst>
+                              <p:par>
+                                <p:cTn id="42" presetID="1" presetClass="entr" presetSubtype="0" fill="hold" grpId="0" nodeType="clickEffect">
+                                  <p:stCondLst>
+                                    <p:cond delay="0"/>
+                                  </p:stCondLst>
+                                  <p:childTnLst>
+                                    <p:set>
+                                      <p:cBhvr>
+                                        <p:cTn id="43" dur="1" fill="hold">
+                                          <p:stCondLst>
+                                            <p:cond delay="0"/>
+                                          </p:stCondLst>
+                                        </p:cTn>
+                                        <p:tgtEl>
+                                          <p:spTgt spid="None"/>
+                                        </p:tgtEl>
+                                        <p:attrNameLst>
+                                          <p:attrName>style.visibility</p:attrName>
+                                        </p:attrNameLst>
+                                      </p:cBhvr>
+                                      <p:to>
+                                        <p:strVal val="visible"/>
+                                      </p:to>
+                                    </p:set>
+                                  </p:childTnLst>
+                                </p:cTn>
+                              </p:par>
+                            </p:childTnLst>
+                          </p:cTn>
+                        </p:par>
+                      </p:childTnLst>
+                    </p:cTn>
+                  </p:par>
+                  <p:par>
+                    <p:cTn id="50" fill="hold">
+                      <p:stCondLst>
+                        <p:cond delay="indefinite"/>
+                      </p:stCondLst>
+                      <p:childTnLst>
+                        <p:par>
+                          <p:cTn id="51" fill="hold">
+                            <p:stCondLst>
+                              <p:cond delay="0"/>
+                            </p:stCondLst>
+                            <p:childTnLst>
+                              <p:par>
+                                <p:cTn id="52" presetID="1" presetClass="entr" presetSubtype="0" fill="hold" grpId="0" nodeType="clickEffect">
+                                  <p:stCondLst>
+                                    <p:cond delay="0"/>
+                                  </p:stCondLst>
+                                  <p:childTnLst>
+                                    <p:set>
+                                      <p:cBhvr>
+                                        <p:cTn id="53" dur="1" fill="hold">
+                                          <p:stCondLst>
+                                            <p:cond delay="0"/>
+                                          </p:stCondLst>
+                                        </p:cTn>
+                                        <p:tgtEl>
+                                          <p:spTgt spid="None"/>
+                                        </p:tgtEl>
+                                        <p:attrNameLst>
+                                          <p:attrName>style.visibility</p:attrName>
+                                        </p:attrNameLst>
+                                      </p:cBhvr>
+                                      <p:to>
+                                        <p:strVal val="visible"/>
+                                      </p:to>
+                                    </p:set>
+                                  </p:childTnLst>
+                                </p:cTn>
+                              </p:par>
+                            </p:childTnLst>
+                          </p:cTn>
+                        </p:par>
+                      </p:childTnLst>
+                    </p:cTn>
+                  </p:par>
+                  <p:par>
+                    <p:cTn id="60" fill="hold">
+                      <p:stCondLst>
+                        <p:cond delay="indefinite"/>
+                      </p:stCondLst>
+                      <p:childTnLst>
+                        <p:par>
+                          <p:cTn id="61" fill="hold">
+                            <p:stCondLst>
+                              <p:cond delay="0"/>
+                            </p:stCondLst>
+                            <p:childTnLst>
+                              <p:par>
+                                <p:cTn id="62" presetID="1" presetClass="entr" presetSubtype="0" fill="hold" grpId="0" nodeType="clickEffect">
+                                  <p:stCondLst>
+                                    <p:cond delay="0"/>
+                                  </p:stCondLst>
+                                  <p:childTnLst>
+                                    <p:set>
+                                      <p:cBhvr>
+                                        <p:cTn id="63" dur="1" fill="hold">
                                           <p:stCondLst>
                                             <p:cond delay="0"/>
                                           </p:stCondLst>

</xml_diff>